<commit_message>
Remove critérios de avaliação da apresentação de apoio
Co-authored-by: Copilot <223556219+Copilot@users.noreply.github.com>
</commit_message>
<xml_diff>
--- a/Azure_Boards_Product_Backlog.pptx
+++ b/Azure_Boards_Product_Backlog.pptx
@@ -5,7 +5,7 @@
     <p:sldMasterId id="2147483648" r:id="rId1"/>
   </p:sldMasterIdLst>
   <p:notesMasterIdLst>
-    <p:notesMasterId r:id="rId40"/>
+    <p:notesMasterId r:id="rId39"/>
   </p:notesMasterIdLst>
   <p:sldIdLst>
     <p:sldId id="256" r:id="rId2"/>
@@ -44,8 +44,7 @@
     <p:sldId id="298" r:id="rId35"/>
     <p:sldId id="299" r:id="rId36"/>
     <p:sldId id="316" r:id="rId37"/>
-    <p:sldId id="311" r:id="rId38"/>
-    <p:sldId id="314" r:id="rId39"/>
+    <p:sldId id="314" r:id="rId38"/>
   </p:sldIdLst>
   <p:sldSz cx="9144000" cy="5143500" type="screen16x9"/>
   <p:notesSz cx="5143500" cy="9144000"/>
@@ -1072,12 +1071,12 @@
           <a:lstStyle/>
           <a:p>
             <a:r>
-              <a:rPr lang="en-US" dirty="0"/>
-              <a:t>Esta é a parte com maior peso na avaliação </a:t>
+              <a:rPr lang="pt-BR"/>
+              <a:t>Esta é a parte central da RA-01: história</a:t>
             </a:r>
             <a:r>
               <a:rPr lang="en-US"/>
-              <a:t>da RA-01: história sem critério </a:t>
+              <a:t> sem critério </a:t>
             </a:r>
             <a:r>
               <a:rPr lang="en-US" dirty="0"/>
@@ -3113,12 +3112,8 @@
           <a:lstStyle/>
           <a:p>
             <a:r>
-              <a:rPr lang="en-US"/>
-              <a:t>Distribuir o roteiro antes </a:t>
-            </a:r>
-            <a:r>
               <a:rPr lang="en-US" dirty="0"/>
-              <a:t>da aula prática. A rubrica detalhada evita a maior parte das dúvidas de correção.</a:t>
+              <a:t>Encerrar reservando os últimos 20 minutos da aula para que cada equipe execute o passo 2 com o docente disponível para desbloqueio.</a:t>
             </a:r>
           </a:p>
         </p:txBody>
@@ -3141,93 +3136,6 @@
             <a:fld id="{F7021451-1387-4CA6-816F-3879F97B5CBC}" type="slidenum">
               <a:rPr lang="en-US"/>
               <a:t>37</a:t>
-            </a:fld>
-            <a:endParaRPr lang="en-US"/>
-          </a:p>
-        </p:txBody>
-      </p:sp>
-    </p:spTree>
-    <p:extLst>
-      <p:ext uri="{BB962C8B-B14F-4D97-AF65-F5344CB8AC3E}">
-        <p14:creationId xmlns:p14="http://schemas.microsoft.com/office/powerpoint/2010/main" val="1024086991"/>
-      </p:ext>
-    </p:extLst>
-  </p:cSld>
-  <p:clrMapOvr>
-    <a:masterClrMapping/>
-  </p:clrMapOvr>
-</p:notes>
-</file>
-
-<file path=ppt/notesSlides/notesSlide38.xml><?xml version="1.0" encoding="utf-8"?>
-<p:notes xmlns:a="http://schemas.openxmlformats.org/drawingml/2006/main" xmlns:r="http://schemas.openxmlformats.org/officeDocument/2006/relationships" xmlns:p="http://schemas.openxmlformats.org/presentationml/2006/main">
-  <p:cSld>
-    <p:spTree>
-      <p:nvGrpSpPr>
-        <p:cNvPr id="1" name=""/>
-        <p:cNvGrpSpPr/>
-        <p:nvPr/>
-      </p:nvGrpSpPr>
-      <p:grpSpPr>
-        <a:xfrm>
-          <a:off x="0" y="0"/>
-          <a:ext cx="0" cy="0"/>
-          <a:chOff x="0" y="0"/>
-          <a:chExt cx="0" cy="0"/>
-        </a:xfrm>
-      </p:grpSpPr>
-      <p:sp>
-        <p:nvSpPr>
-          <p:cNvPr id="2" name="Slide Image Placeholder 1"/>
-          <p:cNvSpPr>
-            <a:spLocks noGrp="1" noRot="1" noChangeAspect="1"/>
-          </p:cNvSpPr>
-          <p:nvPr>
-            <p:ph type="sldImg"/>
-          </p:nvPr>
-        </p:nvSpPr>
-        <p:spPr/>
-      </p:sp>
-      <p:sp>
-        <p:nvSpPr>
-          <p:cNvPr id="3" name="Notes Placeholder 2"/>
-          <p:cNvSpPr>
-            <a:spLocks noGrp="1"/>
-          </p:cNvSpPr>
-          <p:nvPr>
-            <p:ph type="body" idx="1"/>
-          </p:nvPr>
-        </p:nvSpPr>
-        <p:spPr/>
-        <p:txBody>
-          <a:bodyPr/>
-          <a:lstStyle/>
-          <a:p>
-            <a:r>
-              <a:rPr lang="en-US" dirty="0"/>
-              <a:t>Encerrar reservando os últimos 20 minutos da aula para que cada equipe execute o passo 2 com o docente disponível para desbloqueio.</a:t>
-            </a:r>
-          </a:p>
-        </p:txBody>
-      </p:sp>
-      <p:sp>
-        <p:nvSpPr>
-          <p:cNvPr id="4" name="Slide Number Placeholder 3"/>
-          <p:cNvSpPr>
-            <a:spLocks noGrp="1"/>
-          </p:cNvSpPr>
-          <p:nvPr>
-            <p:ph type="sldNum" sz="quarter" idx="10"/>
-          </p:nvPr>
-        </p:nvSpPr>
-        <p:spPr/>
-        <p:txBody>
-          <a:bodyPr/>
-          <a:lstStyle/>
-          <a:p>
-            <a:fld id="{F7021451-1387-4CA6-816F-3879F97B5CBC}" type="slidenum">
-              <a:rPr lang="en-US"/>
-              <a:t>38</a:t>
             </a:fld>
             <a:endParaRPr lang="en-US"/>
           </a:p>
@@ -15054,7 +14962,7 @@
               <a:buNone/>
             </a:pPr>
             <a:r>
-              <a:rPr lang="en-US" sz="1050" dirty="0">
+              <a:rPr lang="pt-BR" sz="1050">
                 <a:solidFill>
                   <a:srgbClr val="5A7184"/>
                 </a:solidFill>
@@ -15062,29 +14970,7 @@
                 <a:ea typeface="Calibri" pitchFamily="34" charset="-122"/>
                 <a:cs typeface="Calibri" pitchFamily="34" charset="-120"/>
               </a:rPr>
-              <a:t>Passo a passo no Azure Boards, entregáveis </a:t>
-            </a:r>
-            <a:r>
-              <a:rPr lang="en-US" sz="1050">
-                <a:solidFill>
-                  <a:srgbClr val="5A7184"/>
-                </a:solidFill>
-                <a:latin typeface="Calibri" pitchFamily="34" charset="0"/>
-                <a:ea typeface="Calibri" pitchFamily="34" charset="-122"/>
-                <a:cs typeface="Calibri" pitchFamily="34" charset="-120"/>
-              </a:rPr>
-              <a:t>e </a:t>
-            </a:r>
-            <a:r>
-              <a:rPr lang="pt-BR" sz="1050">
-                <a:solidFill>
-                  <a:srgbClr val="5A7184"/>
-                </a:solidFill>
-                <a:latin typeface="Calibri" pitchFamily="34" charset="0"/>
-                <a:ea typeface="Calibri" pitchFamily="34" charset="-122"/>
-                <a:cs typeface="Calibri" pitchFamily="34" charset="-120"/>
-              </a:rPr>
-              <a:t>critérios de avaliação da atividade</a:t>
+              <a:t>Passo a passo no Azure Boards e entregáveis da atividade</a:t>
             </a:r>
             <a:endParaRPr lang="en-US" sz="1050" dirty="0"/>
           </a:p>
@@ -25403,7 +25289,7 @@
               <a:buNone/>
             </a:pPr>
             <a:r>
-              <a:rPr lang="en-US" sz="1500" dirty="0">
+              <a:rPr lang="pt-BR" sz="1500">
                 <a:solidFill>
                   <a:srgbClr val="028090"/>
                 </a:solidFill>
@@ -25411,7 +25297,7 @@
                 <a:ea typeface="Calibri" pitchFamily="34" charset="-122"/>
                 <a:cs typeface="Calibri" pitchFamily="34" charset="-120"/>
               </a:rPr>
-              <a:t>Passo a passo no Azure Boards, campos obrigatórios e critérios de avaliação</a:t>
+              <a:t>Passo a passo no Azure Boards, campos obrigatórios e entregáveis</a:t>
             </a:r>
             <a:endParaRPr lang="en-US" sz="1500" dirty="0"/>
           </a:p>
@@ -32016,1504 +31902,6 @@
 
 <file path=ppt/slides/slide37.xml><?xml version="1.0" encoding="utf-8"?>
 <p:sld xmlns:a="http://schemas.openxmlformats.org/drawingml/2006/main" xmlns:r="http://schemas.openxmlformats.org/officeDocument/2006/relationships" xmlns:p="http://schemas.openxmlformats.org/presentationml/2006/main">
-  <p:cSld name="Slide 56">
-    <p:bg>
-      <p:bgPr>
-        <a:solidFill>
-          <a:srgbClr val="D0E1EA"/>
-        </a:solidFill>
-        <a:effectLst/>
-      </p:bgPr>
-    </p:bg>
-    <p:spTree>
-      <p:nvGrpSpPr>
-        <p:cNvPr id="1" name=""/>
-        <p:cNvGrpSpPr/>
-        <p:nvPr/>
-      </p:nvGrpSpPr>
-      <p:grpSpPr>
-        <a:xfrm>
-          <a:off x="0" y="0"/>
-          <a:ext cx="0" cy="0"/>
-          <a:chOff x="0" y="0"/>
-          <a:chExt cx="0" cy="0"/>
-        </a:xfrm>
-      </p:grpSpPr>
-      <p:sp>
-        <p:nvSpPr>
-          <p:cNvPr id="2" name="Shape 0"/>
-          <p:cNvSpPr/>
-          <p:nvPr/>
-        </p:nvSpPr>
-        <p:spPr>
-          <a:xfrm>
-            <a:off x="0" y="0"/>
-            <a:ext cx="9144000" cy="73152"/>
-          </a:xfrm>
-          <a:prstGeom prst="rect">
-            <a:avLst/>
-          </a:prstGeom>
-          <a:solidFill>
-            <a:srgbClr val="028090"/>
-          </a:solidFill>
-          <a:ln w="12700">
-            <a:solidFill>
-              <a:srgbClr val="333333"/>
-            </a:solidFill>
-            <a:prstDash val="solid"/>
-          </a:ln>
-        </p:spPr>
-        <p:txBody>
-          <a:bodyPr/>
-          <a:lstStyle/>
-          <a:p>
-            <a:endParaRPr lang="pt-BR"/>
-          </a:p>
-        </p:txBody>
-      </p:sp>
-      <p:sp>
-        <p:nvSpPr>
-          <p:cNvPr id="3" name="Text 1"/>
-          <p:cNvSpPr/>
-          <p:nvPr/>
-        </p:nvSpPr>
-        <p:spPr>
-          <a:xfrm>
-            <a:off x="457200" y="237744"/>
-            <a:ext cx="8229600" cy="457200"/>
-          </a:xfrm>
-          <a:prstGeom prst="rect">
-            <a:avLst/>
-          </a:prstGeom>
-          <a:noFill/>
-          <a:ln/>
-        </p:spPr>
-        <p:txBody>
-          <a:bodyPr wrap="square" lIns="0" tIns="0" rIns="0" bIns="0" rtlCol="0" anchor="ctr"/>
-          <a:lstStyle/>
-          <a:p>
-            <a:pPr marL="0" indent="0">
-              <a:buNone/>
-            </a:pPr>
-            <a:r>
-              <a:rPr lang="pt-BR" sz="2800" b="1">
-                <a:solidFill>
-                  <a:srgbClr val="065A82"/>
-                </a:solidFill>
-                <a:latin typeface="Trebuchet MS" pitchFamily="34" charset="0"/>
-                <a:ea typeface="Trebuchet MS" pitchFamily="34" charset="-122"/>
-                <a:cs typeface="Trebuchet MS" pitchFamily="34" charset="-120"/>
-              </a:rPr>
-              <a:t>Como a atividade será avaliada</a:t>
-            </a:r>
-            <a:endParaRPr lang="en-US" sz="2800" dirty="0"/>
-          </a:p>
-        </p:txBody>
-      </p:sp>
-      <p:sp>
-        <p:nvSpPr>
-          <p:cNvPr id="4" name="Text 2"/>
-          <p:cNvSpPr/>
-          <p:nvPr/>
-        </p:nvSpPr>
-        <p:spPr>
-          <a:xfrm>
-            <a:off x="457200" y="694944"/>
-            <a:ext cx="8229600" cy="274320"/>
-          </a:xfrm>
-          <a:prstGeom prst="rect">
-            <a:avLst/>
-          </a:prstGeom>
-          <a:noFill/>
-          <a:ln/>
-        </p:spPr>
-        <p:txBody>
-          <a:bodyPr wrap="square" lIns="0" tIns="0" rIns="0" bIns="0" rtlCol="0" anchor="t"/>
-          <a:lstStyle/>
-          <a:p>
-            <a:pPr marL="0" indent="0">
-              <a:buNone/>
-            </a:pPr>
-            <a:r>
-              <a:rPr lang="en-US" sz="1300" dirty="0">
-                <a:solidFill>
-                  <a:srgbClr val="5A7184"/>
-                </a:solidFill>
-                <a:latin typeface="Calibri" pitchFamily="34" charset="0"/>
-                <a:ea typeface="Calibri" pitchFamily="34" charset="-122"/>
-                <a:cs typeface="Calibri" pitchFamily="34" charset="-120"/>
-              </a:rPr>
-              <a:t>Critérios com peso — o detalhamento completo </a:t>
-            </a:r>
-            <a:r>
-              <a:rPr lang="en-US" sz="1300">
-                <a:solidFill>
-                  <a:srgbClr val="5A7184"/>
-                </a:solidFill>
-                <a:latin typeface="Calibri" pitchFamily="34" charset="0"/>
-                <a:ea typeface="Calibri" pitchFamily="34" charset="-122"/>
-                <a:cs typeface="Calibri" pitchFamily="34" charset="-120"/>
-              </a:rPr>
-              <a:t>está no roteiro em Markdown</a:t>
-            </a:r>
-            <a:endParaRPr lang="en-US" sz="1300" dirty="0"/>
-          </a:p>
-        </p:txBody>
-      </p:sp>
-      <p:graphicFrame>
-        <p:nvGraphicFramePr>
-          <p:cNvPr id="57" name="Table 0"/>
-          <p:cNvGraphicFramePr>
-            <a:graphicFrameLocks noGrp="1"/>
-          </p:cNvGraphicFramePr>
-          <p:nvPr>
-            <p:extLst>
-              <p:ext uri="{D42A27DB-BD31-4B8C-83A1-F6EECF244321}">
-                <p14:modId xmlns:p14="http://schemas.microsoft.com/office/powerpoint/2010/main" val="1905119087"/>
-              </p:ext>
-            </p:extLst>
-          </p:nvPr>
-        </p:nvGraphicFramePr>
-        <p:xfrm>
-          <a:off x="457200" y="1078992"/>
-          <a:ext cx="8229600" cy="1975104"/>
-        </p:xfrm>
-        <a:graphic>
-          <a:graphicData uri="http://schemas.openxmlformats.org/drawingml/2006/table">
-            <a:tbl>
-              <a:tblPr/>
-              <a:tblGrid>
-                <a:gridCol w="2286000">
-                  <a:extLst>
-                    <a:ext uri="{9D8B030D-6E8A-4147-A177-3AD203B41FA5}">
-                      <a16:colId xmlns:a16="http://schemas.microsoft.com/office/drawing/2014/main" val="20000"/>
-                    </a:ext>
-                  </a:extLst>
-                </a:gridCol>
-                <a:gridCol w="4937760">
-                  <a:extLst>
-                    <a:ext uri="{9D8B030D-6E8A-4147-A177-3AD203B41FA5}">
-                      <a16:colId xmlns:a16="http://schemas.microsoft.com/office/drawing/2014/main" val="20001"/>
-                    </a:ext>
-                  </a:extLst>
-                </a:gridCol>
-                <a:gridCol w="1005840">
-                  <a:extLst>
-                    <a:ext uri="{9D8B030D-6E8A-4147-A177-3AD203B41FA5}">
-                      <a16:colId xmlns:a16="http://schemas.microsoft.com/office/drawing/2014/main" val="20002"/>
-                    </a:ext>
-                  </a:extLst>
-                </a:gridCol>
-              </a:tblGrid>
-              <a:tr h="329184">
-                <a:tc>
-                  <a:txBody>
-                    <a:bodyPr/>
-                    <a:lstStyle/>
-                    <a:p>
-                      <a:pPr marL="0" indent="0" algn="l">
-                        <a:buNone/>
-                      </a:pPr>
-                      <a:r>
-                        <a:rPr lang="en-US" sz="1150" b="1" dirty="0">
-                          <a:solidFill>
-                            <a:srgbClr val="FFFFFF"/>
-                          </a:solidFill>
-                          <a:latin typeface="Calibri" pitchFamily="34" charset="0"/>
-                          <a:ea typeface="Calibri" pitchFamily="34" charset="-122"/>
-                          <a:cs typeface="Calibri" pitchFamily="34" charset="-120"/>
-                        </a:rPr>
-                        <a:t>Critério</a:t>
-                      </a:r>
-                      <a:endParaRPr lang="en-US" sz="1150" dirty="0">
-                        <a:latin typeface="Calibri" charset="0"/>
-                        <a:ea typeface="Calibri" charset="0"/>
-                        <a:cs typeface="Calibri" charset="0"/>
-                      </a:endParaRPr>
-                    </a:p>
-                  </a:txBody>
-                  <a:tcPr marL="101600" marR="101600" marT="50800" marB="50800" anchor="ctr">
-                    <a:lnL w="12700" cap="flat" cmpd="sng" algn="ctr">
-                      <a:solidFill>
-                        <a:srgbClr val="D0E1EA"/>
-                      </a:solidFill>
-                      <a:prstDash val="solid"/>
-                      <a:round/>
-                      <a:headEnd type="none" w="med" len="med"/>
-                      <a:tailEnd type="none" w="med" len="med"/>
-                    </a:lnL>
-                    <a:lnR w="12700" cap="flat" cmpd="sng" algn="ctr">
-                      <a:solidFill>
-                        <a:srgbClr val="D0E1EA"/>
-                      </a:solidFill>
-                      <a:prstDash val="solid"/>
-                      <a:round/>
-                      <a:headEnd type="none" w="med" len="med"/>
-                      <a:tailEnd type="none" w="med" len="med"/>
-                    </a:lnR>
-                    <a:lnT w="12700" cap="flat" cmpd="sng" algn="ctr">
-                      <a:solidFill>
-                        <a:srgbClr val="D0E1EA"/>
-                      </a:solidFill>
-                      <a:prstDash val="solid"/>
-                      <a:round/>
-                      <a:headEnd type="none" w="med" len="med"/>
-                      <a:tailEnd type="none" w="med" len="med"/>
-                    </a:lnT>
-                    <a:lnB w="12700" cap="flat" cmpd="sng" algn="ctr">
-                      <a:solidFill>
-                        <a:srgbClr val="D0E1EA"/>
-                      </a:solidFill>
-                      <a:prstDash val="solid"/>
-                      <a:round/>
-                      <a:headEnd type="none" w="med" len="med"/>
-                      <a:tailEnd type="none" w="med" len="med"/>
-                    </a:lnB>
-                    <a:solidFill>
-                      <a:srgbClr val="1A2332"/>
-                    </a:solidFill>
-                  </a:tcPr>
-                </a:tc>
-                <a:tc>
-                  <a:txBody>
-                    <a:bodyPr/>
-                    <a:lstStyle/>
-                    <a:p>
-                      <a:pPr marL="0" indent="0" algn="l">
-                        <a:buNone/>
-                      </a:pPr>
-                      <a:r>
-                        <a:rPr lang="en-US" sz="1150" b="1" dirty="0">
-                          <a:solidFill>
-                            <a:srgbClr val="FFFFFF"/>
-                          </a:solidFill>
-                          <a:latin typeface="Calibri" pitchFamily="34" charset="0"/>
-                          <a:ea typeface="Calibri" pitchFamily="34" charset="-122"/>
-                          <a:cs typeface="Calibri" pitchFamily="34" charset="-120"/>
-                        </a:rPr>
-                        <a:t>O que se observa</a:t>
-                      </a:r>
-                      <a:endParaRPr lang="en-US" sz="1150" dirty="0">
-                        <a:latin typeface="Calibri" charset="0"/>
-                        <a:ea typeface="Calibri" charset="0"/>
-                        <a:cs typeface="Calibri" charset="0"/>
-                      </a:endParaRPr>
-                    </a:p>
-                  </a:txBody>
-                  <a:tcPr marL="101600" marR="101600" marT="50800" marB="50800" anchor="ctr">
-                    <a:lnL w="12700" cap="flat" cmpd="sng" algn="ctr">
-                      <a:solidFill>
-                        <a:srgbClr val="D0E1EA"/>
-                      </a:solidFill>
-                      <a:prstDash val="solid"/>
-                      <a:round/>
-                      <a:headEnd type="none" w="med" len="med"/>
-                      <a:tailEnd type="none" w="med" len="med"/>
-                    </a:lnL>
-                    <a:lnR w="12700" cap="flat" cmpd="sng" algn="ctr">
-                      <a:solidFill>
-                        <a:srgbClr val="D0E1EA"/>
-                      </a:solidFill>
-                      <a:prstDash val="solid"/>
-                      <a:round/>
-                      <a:headEnd type="none" w="med" len="med"/>
-                      <a:tailEnd type="none" w="med" len="med"/>
-                    </a:lnR>
-                    <a:lnT w="12700" cap="flat" cmpd="sng" algn="ctr">
-                      <a:solidFill>
-                        <a:srgbClr val="D0E1EA"/>
-                      </a:solidFill>
-                      <a:prstDash val="solid"/>
-                      <a:round/>
-                      <a:headEnd type="none" w="med" len="med"/>
-                      <a:tailEnd type="none" w="med" len="med"/>
-                    </a:lnT>
-                    <a:lnB w="12700" cap="flat" cmpd="sng" algn="ctr">
-                      <a:solidFill>
-                        <a:srgbClr val="D0E1EA"/>
-                      </a:solidFill>
-                      <a:prstDash val="solid"/>
-                      <a:round/>
-                      <a:headEnd type="none" w="med" len="med"/>
-                      <a:tailEnd type="none" w="med" len="med"/>
-                    </a:lnB>
-                    <a:solidFill>
-                      <a:srgbClr val="028090"/>
-                    </a:solidFill>
-                  </a:tcPr>
-                </a:tc>
-                <a:tc>
-                  <a:txBody>
-                    <a:bodyPr/>
-                    <a:lstStyle/>
-                    <a:p>
-                      <a:pPr marL="0" indent="0" algn="l">
-                        <a:buNone/>
-                      </a:pPr>
-                      <a:r>
-                        <a:rPr lang="en-US" sz="1150" b="1" dirty="0">
-                          <a:solidFill>
-                            <a:srgbClr val="FFFFFF"/>
-                          </a:solidFill>
-                          <a:latin typeface="Calibri" pitchFamily="34" charset="0"/>
-                          <a:ea typeface="Calibri" pitchFamily="34" charset="-122"/>
-                          <a:cs typeface="Calibri" pitchFamily="34" charset="-120"/>
-                        </a:rPr>
-                        <a:t>Peso</a:t>
-                      </a:r>
-                      <a:endParaRPr lang="en-US" sz="1150" dirty="0">
-                        <a:latin typeface="Calibri" charset="0"/>
-                        <a:ea typeface="Calibri" charset="0"/>
-                        <a:cs typeface="Calibri" charset="0"/>
-                      </a:endParaRPr>
-                    </a:p>
-                  </a:txBody>
-                  <a:tcPr marL="101600" marR="101600" marT="50800" marB="50800" anchor="ctr">
-                    <a:lnL w="12700" cap="flat" cmpd="sng" algn="ctr">
-                      <a:solidFill>
-                        <a:srgbClr val="D0E1EA"/>
-                      </a:solidFill>
-                      <a:prstDash val="solid"/>
-                      <a:round/>
-                      <a:headEnd type="none" w="med" len="med"/>
-                      <a:tailEnd type="none" w="med" len="med"/>
-                    </a:lnL>
-                    <a:lnR w="12700" cap="flat" cmpd="sng" algn="ctr">
-                      <a:solidFill>
-                        <a:srgbClr val="D0E1EA"/>
-                      </a:solidFill>
-                      <a:prstDash val="solid"/>
-                      <a:round/>
-                      <a:headEnd type="none" w="med" len="med"/>
-                      <a:tailEnd type="none" w="med" len="med"/>
-                    </a:lnR>
-                    <a:lnT w="12700" cap="flat" cmpd="sng" algn="ctr">
-                      <a:solidFill>
-                        <a:srgbClr val="D0E1EA"/>
-                      </a:solidFill>
-                      <a:prstDash val="solid"/>
-                      <a:round/>
-                      <a:headEnd type="none" w="med" len="med"/>
-                      <a:tailEnd type="none" w="med" len="med"/>
-                    </a:lnT>
-                    <a:lnB w="12700" cap="flat" cmpd="sng" algn="ctr">
-                      <a:solidFill>
-                        <a:srgbClr val="D0E1EA"/>
-                      </a:solidFill>
-                      <a:prstDash val="solid"/>
-                      <a:round/>
-                      <a:headEnd type="none" w="med" len="med"/>
-                      <a:tailEnd type="none" w="med" len="med"/>
-                    </a:lnB>
-                    <a:solidFill>
-                      <a:srgbClr val="02C39A"/>
-                    </a:solidFill>
-                  </a:tcPr>
-                </a:tc>
-                <a:extLst>
-                  <a:ext uri="{0D108BD9-81ED-4DB2-BD59-A6C34878D82A}">
-                    <a16:rowId xmlns:a16="http://schemas.microsoft.com/office/drawing/2014/main" val="10000"/>
-                  </a:ext>
-                </a:extLst>
-              </a:tr>
-              <a:tr h="329184">
-                <a:tc>
-                  <a:txBody>
-                    <a:bodyPr/>
-                    <a:lstStyle/>
-                    <a:p>
-                      <a:pPr marL="0" indent="0">
-                        <a:buNone/>
-                      </a:pPr>
-                      <a:r>
-                        <a:rPr lang="en-US" sz="1100" b="1" dirty="0">
-                          <a:solidFill>
-                            <a:srgbClr val="065A82"/>
-                          </a:solidFill>
-                          <a:latin typeface="Calibri" pitchFamily="34" charset="0"/>
-                          <a:ea typeface="Calibri" pitchFamily="34" charset="-122"/>
-                          <a:cs typeface="Calibri" pitchFamily="34" charset="-120"/>
-                        </a:rPr>
-                        <a:t>Estrutura</a:t>
-                      </a:r>
-                      <a:endParaRPr lang="en-US" sz="1100" dirty="0">
-                        <a:latin typeface="Calibri" charset="0"/>
-                        <a:ea typeface="Calibri" charset="0"/>
-                        <a:cs typeface="Calibri" charset="0"/>
-                      </a:endParaRPr>
-                    </a:p>
-                  </a:txBody>
-                  <a:tcPr marL="101600" marR="101600" marT="50800" marB="50800" anchor="ctr">
-                    <a:lnL w="12700" cap="flat" cmpd="sng" algn="ctr">
-                      <a:solidFill>
-                        <a:srgbClr val="D0E1EA"/>
-                      </a:solidFill>
-                      <a:prstDash val="solid"/>
-                      <a:round/>
-                      <a:headEnd type="none" w="med" len="med"/>
-                      <a:tailEnd type="none" w="med" len="med"/>
-                    </a:lnL>
-                    <a:lnR w="12700" cap="flat" cmpd="sng" algn="ctr">
-                      <a:solidFill>
-                        <a:srgbClr val="D0E1EA"/>
-                      </a:solidFill>
-                      <a:prstDash val="solid"/>
-                      <a:round/>
-                      <a:headEnd type="none" w="med" len="med"/>
-                      <a:tailEnd type="none" w="med" len="med"/>
-                    </a:lnR>
-                    <a:lnT w="12700" cap="flat" cmpd="sng" algn="ctr">
-                      <a:solidFill>
-                        <a:srgbClr val="D0E1EA"/>
-                      </a:solidFill>
-                      <a:prstDash val="solid"/>
-                      <a:round/>
-                      <a:headEnd type="none" w="med" len="med"/>
-                      <a:tailEnd type="none" w="med" len="med"/>
-                    </a:lnT>
-                    <a:lnB w="12700" cap="flat" cmpd="sng" algn="ctr">
-                      <a:solidFill>
-                        <a:srgbClr val="D0E1EA"/>
-                      </a:solidFill>
-                      <a:prstDash val="solid"/>
-                      <a:round/>
-                      <a:headEnd type="none" w="med" len="med"/>
-                      <a:tailEnd type="none" w="med" len="med"/>
-                    </a:lnB>
-                    <a:solidFill>
-                      <a:srgbClr val="F1F5F9"/>
-                    </a:solidFill>
-                  </a:tcPr>
-                </a:tc>
-                <a:tc>
-                  <a:txBody>
-                    <a:bodyPr/>
-                    <a:lstStyle/>
-                    <a:p>
-                      <a:pPr marL="0" indent="0">
-                        <a:buNone/>
-                      </a:pPr>
-                      <a:r>
-                        <a:rPr lang="en-US" sz="1100" dirty="0">
-                          <a:solidFill>
-                            <a:srgbClr val="334155"/>
-                          </a:solidFill>
-                          <a:latin typeface="Calibri" pitchFamily="34" charset="0"/>
-                          <a:ea typeface="Calibri" pitchFamily="34" charset="-122"/>
-                          <a:cs typeface="Calibri" pitchFamily="34" charset="-120"/>
-                        </a:rPr>
-                        <a:t>Hierarquia correta, sem itens órfãos e sem erro de nível</a:t>
-                      </a:r>
-                      <a:endParaRPr lang="en-US" sz="1100" dirty="0">
-                        <a:latin typeface="Calibri" charset="0"/>
-                        <a:ea typeface="Calibri" charset="0"/>
-                        <a:cs typeface="Calibri" charset="0"/>
-                      </a:endParaRPr>
-                    </a:p>
-                  </a:txBody>
-                  <a:tcPr marL="101600" marR="101600" marT="50800" marB="50800" anchor="ctr">
-                    <a:lnL w="12700" cap="flat" cmpd="sng" algn="ctr">
-                      <a:solidFill>
-                        <a:srgbClr val="D0E1EA"/>
-                      </a:solidFill>
-                      <a:prstDash val="solid"/>
-                      <a:round/>
-                      <a:headEnd type="none" w="med" len="med"/>
-                      <a:tailEnd type="none" w="med" len="med"/>
-                    </a:lnL>
-                    <a:lnR w="12700" cap="flat" cmpd="sng" algn="ctr">
-                      <a:solidFill>
-                        <a:srgbClr val="D0E1EA"/>
-                      </a:solidFill>
-                      <a:prstDash val="solid"/>
-                      <a:round/>
-                      <a:headEnd type="none" w="med" len="med"/>
-                      <a:tailEnd type="none" w="med" len="med"/>
-                    </a:lnR>
-                    <a:lnT w="12700" cap="flat" cmpd="sng" algn="ctr">
-                      <a:solidFill>
-                        <a:srgbClr val="D0E1EA"/>
-                      </a:solidFill>
-                      <a:prstDash val="solid"/>
-                      <a:round/>
-                      <a:headEnd type="none" w="med" len="med"/>
-                      <a:tailEnd type="none" w="med" len="med"/>
-                    </a:lnT>
-                    <a:lnB w="12700" cap="flat" cmpd="sng" algn="ctr">
-                      <a:solidFill>
-                        <a:srgbClr val="D0E1EA"/>
-                      </a:solidFill>
-                      <a:prstDash val="solid"/>
-                      <a:round/>
-                      <a:headEnd type="none" w="med" len="med"/>
-                      <a:tailEnd type="none" w="med" len="med"/>
-                    </a:lnB>
-                    <a:solidFill>
-                      <a:srgbClr val="FFFFFF"/>
-                    </a:solidFill>
-                  </a:tcPr>
-                </a:tc>
-                <a:tc>
-                  <a:txBody>
-                    <a:bodyPr/>
-                    <a:lstStyle/>
-                    <a:p>
-                      <a:pPr marL="0" indent="0">
-                        <a:buNone/>
-                      </a:pPr>
-                      <a:r>
-                        <a:rPr lang="en-US" sz="1100">
-                          <a:solidFill>
-                            <a:srgbClr val="334155"/>
-                          </a:solidFill>
-                          <a:latin typeface="Calibri" pitchFamily="34" charset="0"/>
-                          <a:ea typeface="Calibri" pitchFamily="34" charset="-122"/>
-                          <a:cs typeface="Calibri" pitchFamily="34" charset="-120"/>
-                        </a:rPr>
-                        <a:t>25%</a:t>
-                      </a:r>
-                      <a:endParaRPr lang="en-US" sz="1100" dirty="0">
-                        <a:latin typeface="Calibri" charset="0"/>
-                        <a:ea typeface="Calibri" charset="0"/>
-                        <a:cs typeface="Calibri" charset="0"/>
-                      </a:endParaRPr>
-                    </a:p>
-                  </a:txBody>
-                  <a:tcPr marL="101600" marR="101600" marT="50800" marB="50800" anchor="ctr">
-                    <a:lnL w="12700" cap="flat" cmpd="sng" algn="ctr">
-                      <a:solidFill>
-                        <a:srgbClr val="D0E1EA"/>
-                      </a:solidFill>
-                      <a:prstDash val="solid"/>
-                      <a:round/>
-                      <a:headEnd type="none" w="med" len="med"/>
-                      <a:tailEnd type="none" w="med" len="med"/>
-                    </a:lnL>
-                    <a:lnR w="12700" cap="flat" cmpd="sng" algn="ctr">
-                      <a:solidFill>
-                        <a:srgbClr val="D0E1EA"/>
-                      </a:solidFill>
-                      <a:prstDash val="solid"/>
-                      <a:round/>
-                      <a:headEnd type="none" w="med" len="med"/>
-                      <a:tailEnd type="none" w="med" len="med"/>
-                    </a:lnR>
-                    <a:lnT w="12700" cap="flat" cmpd="sng" algn="ctr">
-                      <a:solidFill>
-                        <a:srgbClr val="D0E1EA"/>
-                      </a:solidFill>
-                      <a:prstDash val="solid"/>
-                      <a:round/>
-                      <a:headEnd type="none" w="med" len="med"/>
-                      <a:tailEnd type="none" w="med" len="med"/>
-                    </a:lnT>
-                    <a:lnB w="12700" cap="flat" cmpd="sng" algn="ctr">
-                      <a:solidFill>
-                        <a:srgbClr val="D0E1EA"/>
-                      </a:solidFill>
-                      <a:prstDash val="solid"/>
-                      <a:round/>
-                      <a:headEnd type="none" w="med" len="med"/>
-                      <a:tailEnd type="none" w="med" len="med"/>
-                    </a:lnB>
-                    <a:solidFill>
-                      <a:srgbClr val="FFFFFF"/>
-                    </a:solidFill>
-                  </a:tcPr>
-                </a:tc>
-                <a:extLst>
-                  <a:ext uri="{0D108BD9-81ED-4DB2-BD59-A6C34878D82A}">
-                    <a16:rowId xmlns:a16="http://schemas.microsoft.com/office/drawing/2014/main" val="10001"/>
-                  </a:ext>
-                </a:extLst>
-              </a:tr>
-              <a:tr h="329184">
-                <a:tc>
-                  <a:txBody>
-                    <a:bodyPr/>
-                    <a:lstStyle/>
-                    <a:p>
-                      <a:pPr marL="0" indent="0">
-                        <a:buNone/>
-                      </a:pPr>
-                      <a:r>
-                        <a:rPr lang="en-US" sz="1100" b="1" dirty="0">
-                          <a:solidFill>
-                            <a:srgbClr val="065A82"/>
-                          </a:solidFill>
-                          <a:latin typeface="Calibri" pitchFamily="34" charset="0"/>
-                          <a:ea typeface="Calibri" pitchFamily="34" charset="-122"/>
-                          <a:cs typeface="Calibri" pitchFamily="34" charset="-120"/>
-                        </a:rPr>
-                        <a:t>Qualidade das histórias</a:t>
-                      </a:r>
-                      <a:endParaRPr lang="en-US" sz="1100" dirty="0">
-                        <a:latin typeface="Calibri" charset="0"/>
-                        <a:ea typeface="Calibri" charset="0"/>
-                        <a:cs typeface="Calibri" charset="0"/>
-                      </a:endParaRPr>
-                    </a:p>
-                  </a:txBody>
-                  <a:tcPr marL="101600" marR="101600" marT="50800" marB="50800" anchor="ctr">
-                    <a:lnL w="12700" cap="flat" cmpd="sng" algn="ctr">
-                      <a:solidFill>
-                        <a:srgbClr val="D0E1EA"/>
-                      </a:solidFill>
-                      <a:prstDash val="solid"/>
-                      <a:round/>
-                      <a:headEnd type="none" w="med" len="med"/>
-                      <a:tailEnd type="none" w="med" len="med"/>
-                    </a:lnL>
-                    <a:lnR w="12700" cap="flat" cmpd="sng" algn="ctr">
-                      <a:solidFill>
-                        <a:srgbClr val="D0E1EA"/>
-                      </a:solidFill>
-                      <a:prstDash val="solid"/>
-                      <a:round/>
-                      <a:headEnd type="none" w="med" len="med"/>
-                      <a:tailEnd type="none" w="med" len="med"/>
-                    </a:lnR>
-                    <a:lnT w="12700" cap="flat" cmpd="sng" algn="ctr">
-                      <a:solidFill>
-                        <a:srgbClr val="D0E1EA"/>
-                      </a:solidFill>
-                      <a:prstDash val="solid"/>
-                      <a:round/>
-                      <a:headEnd type="none" w="med" len="med"/>
-                      <a:tailEnd type="none" w="med" len="med"/>
-                    </a:lnT>
-                    <a:lnB w="12700" cap="flat" cmpd="sng" algn="ctr">
-                      <a:solidFill>
-                        <a:srgbClr val="D0E1EA"/>
-                      </a:solidFill>
-                      <a:prstDash val="solid"/>
-                      <a:round/>
-                      <a:headEnd type="none" w="med" len="med"/>
-                      <a:tailEnd type="none" w="med" len="med"/>
-                    </a:lnB>
-                    <a:solidFill>
-                      <a:srgbClr val="F1F5F9"/>
-                    </a:solidFill>
-                  </a:tcPr>
-                </a:tc>
-                <a:tc>
-                  <a:txBody>
-                    <a:bodyPr/>
-                    <a:lstStyle/>
-                    <a:p>
-                      <a:pPr marL="0" indent="0">
-                        <a:buNone/>
-                      </a:pPr>
-                      <a:r>
-                        <a:rPr lang="en-US" sz="1100" dirty="0">
-                          <a:solidFill>
-                            <a:srgbClr val="334155"/>
-                          </a:solidFill>
-                          <a:latin typeface="Calibri" pitchFamily="34" charset="0"/>
-                          <a:ea typeface="Calibri" pitchFamily="34" charset="-122"/>
-                          <a:cs typeface="Calibri" pitchFamily="34" charset="-120"/>
-                        </a:rPr>
-                        <a:t>Forma completa, INVEST atendido, fatia vertical preservada</a:t>
-                      </a:r>
-                      <a:endParaRPr lang="en-US" sz="1100" dirty="0">
-                        <a:latin typeface="Calibri" charset="0"/>
-                        <a:ea typeface="Calibri" charset="0"/>
-                        <a:cs typeface="Calibri" charset="0"/>
-                      </a:endParaRPr>
-                    </a:p>
-                  </a:txBody>
-                  <a:tcPr marL="101600" marR="101600" marT="50800" marB="50800" anchor="ctr">
-                    <a:lnL w="12700" cap="flat" cmpd="sng" algn="ctr">
-                      <a:solidFill>
-                        <a:srgbClr val="D0E1EA"/>
-                      </a:solidFill>
-                      <a:prstDash val="solid"/>
-                      <a:round/>
-                      <a:headEnd type="none" w="med" len="med"/>
-                      <a:tailEnd type="none" w="med" len="med"/>
-                    </a:lnL>
-                    <a:lnR w="12700" cap="flat" cmpd="sng" algn="ctr">
-                      <a:solidFill>
-                        <a:srgbClr val="D0E1EA"/>
-                      </a:solidFill>
-                      <a:prstDash val="solid"/>
-                      <a:round/>
-                      <a:headEnd type="none" w="med" len="med"/>
-                      <a:tailEnd type="none" w="med" len="med"/>
-                    </a:lnR>
-                    <a:lnT w="12700" cap="flat" cmpd="sng" algn="ctr">
-                      <a:solidFill>
-                        <a:srgbClr val="D0E1EA"/>
-                      </a:solidFill>
-                      <a:prstDash val="solid"/>
-                      <a:round/>
-                      <a:headEnd type="none" w="med" len="med"/>
-                      <a:tailEnd type="none" w="med" len="med"/>
-                    </a:lnT>
-                    <a:lnB w="12700" cap="flat" cmpd="sng" algn="ctr">
-                      <a:solidFill>
-                        <a:srgbClr val="D0E1EA"/>
-                      </a:solidFill>
-                      <a:prstDash val="solid"/>
-                      <a:round/>
-                      <a:headEnd type="none" w="med" len="med"/>
-                      <a:tailEnd type="none" w="med" len="med"/>
-                    </a:lnB>
-                    <a:solidFill>
-                      <a:srgbClr val="F0F7FA"/>
-                    </a:solidFill>
-                  </a:tcPr>
-                </a:tc>
-                <a:tc>
-                  <a:txBody>
-                    <a:bodyPr/>
-                    <a:lstStyle/>
-                    <a:p>
-                      <a:pPr marL="0" indent="0">
-                        <a:buNone/>
-                      </a:pPr>
-                      <a:r>
-                        <a:rPr lang="en-US" sz="1100">
-                          <a:solidFill>
-                            <a:srgbClr val="334155"/>
-                          </a:solidFill>
-                          <a:latin typeface="Calibri" pitchFamily="34" charset="0"/>
-                          <a:ea typeface="Calibri" pitchFamily="34" charset="-122"/>
-                          <a:cs typeface="Calibri" pitchFamily="34" charset="-120"/>
-                        </a:rPr>
-                        <a:t>30%</a:t>
-                      </a:r>
-                      <a:endParaRPr lang="en-US" sz="1100" dirty="0">
-                        <a:latin typeface="Calibri" charset="0"/>
-                        <a:ea typeface="Calibri" charset="0"/>
-                        <a:cs typeface="Calibri" charset="0"/>
-                      </a:endParaRPr>
-                    </a:p>
-                  </a:txBody>
-                  <a:tcPr marL="101600" marR="101600" marT="50800" marB="50800" anchor="ctr">
-                    <a:lnL w="12700" cap="flat" cmpd="sng" algn="ctr">
-                      <a:solidFill>
-                        <a:srgbClr val="D0E1EA"/>
-                      </a:solidFill>
-                      <a:prstDash val="solid"/>
-                      <a:round/>
-                      <a:headEnd type="none" w="med" len="med"/>
-                      <a:tailEnd type="none" w="med" len="med"/>
-                    </a:lnL>
-                    <a:lnR w="12700" cap="flat" cmpd="sng" algn="ctr">
-                      <a:solidFill>
-                        <a:srgbClr val="D0E1EA"/>
-                      </a:solidFill>
-                      <a:prstDash val="solid"/>
-                      <a:round/>
-                      <a:headEnd type="none" w="med" len="med"/>
-                      <a:tailEnd type="none" w="med" len="med"/>
-                    </a:lnR>
-                    <a:lnT w="12700" cap="flat" cmpd="sng" algn="ctr">
-                      <a:solidFill>
-                        <a:srgbClr val="D0E1EA"/>
-                      </a:solidFill>
-                      <a:prstDash val="solid"/>
-                      <a:round/>
-                      <a:headEnd type="none" w="med" len="med"/>
-                      <a:tailEnd type="none" w="med" len="med"/>
-                    </a:lnT>
-                    <a:lnB w="12700" cap="flat" cmpd="sng" algn="ctr">
-                      <a:solidFill>
-                        <a:srgbClr val="D0E1EA"/>
-                      </a:solidFill>
-                      <a:prstDash val="solid"/>
-                      <a:round/>
-                      <a:headEnd type="none" w="med" len="med"/>
-                      <a:tailEnd type="none" w="med" len="med"/>
-                    </a:lnB>
-                    <a:solidFill>
-                      <a:srgbClr val="F0F7FA"/>
-                    </a:solidFill>
-                  </a:tcPr>
-                </a:tc>
-                <a:extLst>
-                  <a:ext uri="{0D108BD9-81ED-4DB2-BD59-A6C34878D82A}">
-                    <a16:rowId xmlns:a16="http://schemas.microsoft.com/office/drawing/2014/main" val="10002"/>
-                  </a:ext>
-                </a:extLst>
-              </a:tr>
-              <a:tr h="329184">
-                <a:tc>
-                  <a:txBody>
-                    <a:bodyPr/>
-                    <a:lstStyle/>
-                    <a:p>
-                      <a:pPr marL="0" indent="0">
-                        <a:buNone/>
-                      </a:pPr>
-                      <a:r>
-                        <a:rPr lang="en-US" sz="1100" b="1" dirty="0">
-                          <a:solidFill>
-                            <a:srgbClr val="065A82"/>
-                          </a:solidFill>
-                          <a:latin typeface="Calibri" pitchFamily="34" charset="0"/>
-                          <a:ea typeface="Calibri" pitchFamily="34" charset="-122"/>
-                          <a:cs typeface="Calibri" pitchFamily="34" charset="-120"/>
-                        </a:rPr>
-                        <a:t>Critérios de aceite</a:t>
-                      </a:r>
-                      <a:endParaRPr lang="en-US" sz="1100" dirty="0">
-                        <a:latin typeface="Calibri" charset="0"/>
-                        <a:ea typeface="Calibri" charset="0"/>
-                        <a:cs typeface="Calibri" charset="0"/>
-                      </a:endParaRPr>
-                    </a:p>
-                  </a:txBody>
-                  <a:tcPr marL="101600" marR="101600" marT="50800" marB="50800" anchor="ctr">
-                    <a:lnL w="12700" cap="flat" cmpd="sng" algn="ctr">
-                      <a:solidFill>
-                        <a:srgbClr val="D0E1EA"/>
-                      </a:solidFill>
-                      <a:prstDash val="solid"/>
-                      <a:round/>
-                      <a:headEnd type="none" w="med" len="med"/>
-                      <a:tailEnd type="none" w="med" len="med"/>
-                    </a:lnL>
-                    <a:lnR w="12700" cap="flat" cmpd="sng" algn="ctr">
-                      <a:solidFill>
-                        <a:srgbClr val="D0E1EA"/>
-                      </a:solidFill>
-                      <a:prstDash val="solid"/>
-                      <a:round/>
-                      <a:headEnd type="none" w="med" len="med"/>
-                      <a:tailEnd type="none" w="med" len="med"/>
-                    </a:lnR>
-                    <a:lnT w="12700" cap="flat" cmpd="sng" algn="ctr">
-                      <a:solidFill>
-                        <a:srgbClr val="D0E1EA"/>
-                      </a:solidFill>
-                      <a:prstDash val="solid"/>
-                      <a:round/>
-                      <a:headEnd type="none" w="med" len="med"/>
-                      <a:tailEnd type="none" w="med" len="med"/>
-                    </a:lnT>
-                    <a:lnB w="12700" cap="flat" cmpd="sng" algn="ctr">
-                      <a:solidFill>
-                        <a:srgbClr val="D0E1EA"/>
-                      </a:solidFill>
-                      <a:prstDash val="solid"/>
-                      <a:round/>
-                      <a:headEnd type="none" w="med" len="med"/>
-                      <a:tailEnd type="none" w="med" len="med"/>
-                    </a:lnB>
-                    <a:solidFill>
-                      <a:srgbClr val="F1F5F9"/>
-                    </a:solidFill>
-                  </a:tcPr>
-                </a:tc>
-                <a:tc>
-                  <a:txBody>
-                    <a:bodyPr/>
-                    <a:lstStyle/>
-                    <a:p>
-                      <a:pPr marL="0" indent="0">
-                        <a:buNone/>
-                      </a:pPr>
-                      <a:r>
-                        <a:rPr lang="en-US" sz="1100" dirty="0">
-                          <a:solidFill>
-                            <a:srgbClr val="334155"/>
-                          </a:solidFill>
-                          <a:latin typeface="Calibri" pitchFamily="34" charset="0"/>
-                          <a:ea typeface="Calibri" pitchFamily="34" charset="-122"/>
-                          <a:cs typeface="Calibri" pitchFamily="34" charset="-120"/>
-                        </a:rPr>
-                        <a:t>Gherkin verificável, com caminho de exceção em toda história</a:t>
-                      </a:r>
-                      <a:endParaRPr lang="en-US" sz="1100" dirty="0">
-                        <a:latin typeface="Calibri" charset="0"/>
-                        <a:ea typeface="Calibri" charset="0"/>
-                        <a:cs typeface="Calibri" charset="0"/>
-                      </a:endParaRPr>
-                    </a:p>
-                  </a:txBody>
-                  <a:tcPr marL="101600" marR="101600" marT="50800" marB="50800" anchor="ctr">
-                    <a:lnL w="12700" cap="flat" cmpd="sng" algn="ctr">
-                      <a:solidFill>
-                        <a:srgbClr val="D0E1EA"/>
-                      </a:solidFill>
-                      <a:prstDash val="solid"/>
-                      <a:round/>
-                      <a:headEnd type="none" w="med" len="med"/>
-                      <a:tailEnd type="none" w="med" len="med"/>
-                    </a:lnL>
-                    <a:lnR w="12700" cap="flat" cmpd="sng" algn="ctr">
-                      <a:solidFill>
-                        <a:srgbClr val="D0E1EA"/>
-                      </a:solidFill>
-                      <a:prstDash val="solid"/>
-                      <a:round/>
-                      <a:headEnd type="none" w="med" len="med"/>
-                      <a:tailEnd type="none" w="med" len="med"/>
-                    </a:lnR>
-                    <a:lnT w="12700" cap="flat" cmpd="sng" algn="ctr">
-                      <a:solidFill>
-                        <a:srgbClr val="D0E1EA"/>
-                      </a:solidFill>
-                      <a:prstDash val="solid"/>
-                      <a:round/>
-                      <a:headEnd type="none" w="med" len="med"/>
-                      <a:tailEnd type="none" w="med" len="med"/>
-                    </a:lnT>
-                    <a:lnB w="12700" cap="flat" cmpd="sng" algn="ctr">
-                      <a:solidFill>
-                        <a:srgbClr val="D0E1EA"/>
-                      </a:solidFill>
-                      <a:prstDash val="solid"/>
-                      <a:round/>
-                      <a:headEnd type="none" w="med" len="med"/>
-                      <a:tailEnd type="none" w="med" len="med"/>
-                    </a:lnB>
-                    <a:solidFill>
-                      <a:srgbClr val="FFFFFF"/>
-                    </a:solidFill>
-                  </a:tcPr>
-                </a:tc>
-                <a:tc>
-                  <a:txBody>
-                    <a:bodyPr/>
-                    <a:lstStyle/>
-                    <a:p>
-                      <a:pPr marL="0" indent="0">
-                        <a:buNone/>
-                      </a:pPr>
-                      <a:r>
-                        <a:rPr lang="en-US" sz="1100">
-                          <a:solidFill>
-                            <a:srgbClr val="334155"/>
-                          </a:solidFill>
-                          <a:latin typeface="Calibri" pitchFamily="34" charset="0"/>
-                          <a:ea typeface="Calibri" pitchFamily="34" charset="-122"/>
-                          <a:cs typeface="Calibri" pitchFamily="34" charset="-120"/>
-                        </a:rPr>
-                        <a:t>25%</a:t>
-                      </a:r>
-                      <a:endParaRPr lang="en-US" sz="1100" dirty="0">
-                        <a:latin typeface="Calibri" charset="0"/>
-                        <a:ea typeface="Calibri" charset="0"/>
-                        <a:cs typeface="Calibri" charset="0"/>
-                      </a:endParaRPr>
-                    </a:p>
-                  </a:txBody>
-                  <a:tcPr marL="101600" marR="101600" marT="50800" marB="50800" anchor="ctr">
-                    <a:lnL w="12700" cap="flat" cmpd="sng" algn="ctr">
-                      <a:solidFill>
-                        <a:srgbClr val="D0E1EA"/>
-                      </a:solidFill>
-                      <a:prstDash val="solid"/>
-                      <a:round/>
-                      <a:headEnd type="none" w="med" len="med"/>
-                      <a:tailEnd type="none" w="med" len="med"/>
-                    </a:lnL>
-                    <a:lnR w="12700" cap="flat" cmpd="sng" algn="ctr">
-                      <a:solidFill>
-                        <a:srgbClr val="D0E1EA"/>
-                      </a:solidFill>
-                      <a:prstDash val="solid"/>
-                      <a:round/>
-                      <a:headEnd type="none" w="med" len="med"/>
-                      <a:tailEnd type="none" w="med" len="med"/>
-                    </a:lnR>
-                    <a:lnT w="12700" cap="flat" cmpd="sng" algn="ctr">
-                      <a:solidFill>
-                        <a:srgbClr val="D0E1EA"/>
-                      </a:solidFill>
-                      <a:prstDash val="solid"/>
-                      <a:round/>
-                      <a:headEnd type="none" w="med" len="med"/>
-                      <a:tailEnd type="none" w="med" len="med"/>
-                    </a:lnT>
-                    <a:lnB w="12700" cap="flat" cmpd="sng" algn="ctr">
-                      <a:solidFill>
-                        <a:srgbClr val="D0E1EA"/>
-                      </a:solidFill>
-                      <a:prstDash val="solid"/>
-                      <a:round/>
-                      <a:headEnd type="none" w="med" len="med"/>
-                      <a:tailEnd type="none" w="med" len="med"/>
-                    </a:lnB>
-                    <a:solidFill>
-                      <a:srgbClr val="FFFFFF"/>
-                    </a:solidFill>
-                  </a:tcPr>
-                </a:tc>
-                <a:extLst>
-                  <a:ext uri="{0D108BD9-81ED-4DB2-BD59-A6C34878D82A}">
-                    <a16:rowId xmlns:a16="http://schemas.microsoft.com/office/drawing/2014/main" val="10003"/>
-                  </a:ext>
-                </a:extLst>
-              </a:tr>
-              <a:tr h="329184">
-                <a:tc>
-                  <a:txBody>
-                    <a:bodyPr/>
-                    <a:lstStyle/>
-                    <a:p>
-                      <a:pPr marL="0" indent="0">
-                        <a:buNone/>
-                      </a:pPr>
-                      <a:r>
-                        <a:rPr lang="en-US" sz="1100" b="1" dirty="0">
-                          <a:solidFill>
-                            <a:srgbClr val="065A82"/>
-                          </a:solidFill>
-                          <a:latin typeface="Calibri" pitchFamily="34" charset="0"/>
-                          <a:ea typeface="Calibri" pitchFamily="34" charset="-122"/>
-                          <a:cs typeface="Calibri" pitchFamily="34" charset="-120"/>
-                        </a:rPr>
-                        <a:t>Priorização</a:t>
-                      </a:r>
-                      <a:endParaRPr lang="en-US" sz="1100" dirty="0">
-                        <a:latin typeface="Calibri" charset="0"/>
-                        <a:ea typeface="Calibri" charset="0"/>
-                        <a:cs typeface="Calibri" charset="0"/>
-                      </a:endParaRPr>
-                    </a:p>
-                  </a:txBody>
-                  <a:tcPr marL="101600" marR="101600" marT="50800" marB="50800" anchor="ctr">
-                    <a:lnL w="12700" cap="flat" cmpd="sng" algn="ctr">
-                      <a:solidFill>
-                        <a:srgbClr val="D0E1EA"/>
-                      </a:solidFill>
-                      <a:prstDash val="solid"/>
-                      <a:round/>
-                      <a:headEnd type="none" w="med" len="med"/>
-                      <a:tailEnd type="none" w="med" len="med"/>
-                    </a:lnL>
-                    <a:lnR w="12700" cap="flat" cmpd="sng" algn="ctr">
-                      <a:solidFill>
-                        <a:srgbClr val="D0E1EA"/>
-                      </a:solidFill>
-                      <a:prstDash val="solid"/>
-                      <a:round/>
-                      <a:headEnd type="none" w="med" len="med"/>
-                      <a:tailEnd type="none" w="med" len="med"/>
-                    </a:lnR>
-                    <a:lnT w="12700" cap="flat" cmpd="sng" algn="ctr">
-                      <a:solidFill>
-                        <a:srgbClr val="D0E1EA"/>
-                      </a:solidFill>
-                      <a:prstDash val="solid"/>
-                      <a:round/>
-                      <a:headEnd type="none" w="med" len="med"/>
-                      <a:tailEnd type="none" w="med" len="med"/>
-                    </a:lnT>
-                    <a:lnB w="12700" cap="flat" cmpd="sng" algn="ctr">
-                      <a:solidFill>
-                        <a:srgbClr val="D0E1EA"/>
-                      </a:solidFill>
-                      <a:prstDash val="solid"/>
-                      <a:round/>
-                      <a:headEnd type="none" w="med" len="med"/>
-                      <a:tailEnd type="none" w="med" len="med"/>
-                    </a:lnB>
-                    <a:solidFill>
-                      <a:srgbClr val="F1F5F9"/>
-                    </a:solidFill>
-                  </a:tcPr>
-                </a:tc>
-                <a:tc>
-                  <a:txBody>
-                    <a:bodyPr/>
-                    <a:lstStyle/>
-                    <a:p>
-                      <a:pPr marL="0" indent="0">
-                        <a:buNone/>
-                      </a:pPr>
-                      <a:r>
-                        <a:rPr lang="en-US" sz="1100" dirty="0">
-                          <a:solidFill>
-                            <a:srgbClr val="334155"/>
-                          </a:solidFill>
-                          <a:latin typeface="Calibri" pitchFamily="34" charset="0"/>
-                          <a:ea typeface="Calibri" pitchFamily="34" charset="-122"/>
-                          <a:cs typeface="Calibri" pitchFamily="34" charset="-120"/>
-                        </a:rPr>
-                        <a:t>Ordem justificada a partir do briefing, MoSCoW coerente</a:t>
-                      </a:r>
-                      <a:endParaRPr lang="en-US" sz="1100" dirty="0">
-                        <a:latin typeface="Calibri" charset="0"/>
-                        <a:ea typeface="Calibri" charset="0"/>
-                        <a:cs typeface="Calibri" charset="0"/>
-                      </a:endParaRPr>
-                    </a:p>
-                  </a:txBody>
-                  <a:tcPr marL="101600" marR="101600" marT="50800" marB="50800" anchor="ctr">
-                    <a:lnL w="12700" cap="flat" cmpd="sng" algn="ctr">
-                      <a:solidFill>
-                        <a:srgbClr val="D0E1EA"/>
-                      </a:solidFill>
-                      <a:prstDash val="solid"/>
-                      <a:round/>
-                      <a:headEnd type="none" w="med" len="med"/>
-                      <a:tailEnd type="none" w="med" len="med"/>
-                    </a:lnL>
-                    <a:lnR w="12700" cap="flat" cmpd="sng" algn="ctr">
-                      <a:solidFill>
-                        <a:srgbClr val="D0E1EA"/>
-                      </a:solidFill>
-                      <a:prstDash val="solid"/>
-                      <a:round/>
-                      <a:headEnd type="none" w="med" len="med"/>
-                      <a:tailEnd type="none" w="med" len="med"/>
-                    </a:lnR>
-                    <a:lnT w="12700" cap="flat" cmpd="sng" algn="ctr">
-                      <a:solidFill>
-                        <a:srgbClr val="D0E1EA"/>
-                      </a:solidFill>
-                      <a:prstDash val="solid"/>
-                      <a:round/>
-                      <a:headEnd type="none" w="med" len="med"/>
-                      <a:tailEnd type="none" w="med" len="med"/>
-                    </a:lnT>
-                    <a:lnB w="12700" cap="flat" cmpd="sng" algn="ctr">
-                      <a:solidFill>
-                        <a:srgbClr val="D0E1EA"/>
-                      </a:solidFill>
-                      <a:prstDash val="solid"/>
-                      <a:round/>
-                      <a:headEnd type="none" w="med" len="med"/>
-                      <a:tailEnd type="none" w="med" len="med"/>
-                    </a:lnB>
-                    <a:solidFill>
-                      <a:srgbClr val="F0F7FA"/>
-                    </a:solidFill>
-                  </a:tcPr>
-                </a:tc>
-                <a:tc>
-                  <a:txBody>
-                    <a:bodyPr/>
-                    <a:lstStyle/>
-                    <a:p>
-                      <a:pPr marL="0" indent="0">
-                        <a:buNone/>
-                      </a:pPr>
-                      <a:r>
-                        <a:rPr lang="en-US" sz="1100">
-                          <a:solidFill>
-                            <a:srgbClr val="334155"/>
-                          </a:solidFill>
-                          <a:latin typeface="Calibri" pitchFamily="34" charset="0"/>
-                          <a:ea typeface="Calibri" pitchFamily="34" charset="-122"/>
-                          <a:cs typeface="Calibri" pitchFamily="34" charset="-120"/>
-                        </a:rPr>
-                        <a:t>20%</a:t>
-                      </a:r>
-                      <a:endParaRPr lang="en-US" sz="1100" dirty="0">
-                        <a:latin typeface="Calibri" charset="0"/>
-                        <a:ea typeface="Calibri" charset="0"/>
-                        <a:cs typeface="Calibri" charset="0"/>
-                      </a:endParaRPr>
-                    </a:p>
-                  </a:txBody>
-                  <a:tcPr marL="101600" marR="101600" marT="50800" marB="50800" anchor="ctr">
-                    <a:lnL w="12700" cap="flat" cmpd="sng" algn="ctr">
-                      <a:solidFill>
-                        <a:srgbClr val="D0E1EA"/>
-                      </a:solidFill>
-                      <a:prstDash val="solid"/>
-                      <a:round/>
-                      <a:headEnd type="none" w="med" len="med"/>
-                      <a:tailEnd type="none" w="med" len="med"/>
-                    </a:lnL>
-                    <a:lnR w="12700" cap="flat" cmpd="sng" algn="ctr">
-                      <a:solidFill>
-                        <a:srgbClr val="D0E1EA"/>
-                      </a:solidFill>
-                      <a:prstDash val="solid"/>
-                      <a:round/>
-                      <a:headEnd type="none" w="med" len="med"/>
-                      <a:tailEnd type="none" w="med" len="med"/>
-                    </a:lnR>
-                    <a:lnT w="12700" cap="flat" cmpd="sng" algn="ctr">
-                      <a:solidFill>
-                        <a:srgbClr val="D0E1EA"/>
-                      </a:solidFill>
-                      <a:prstDash val="solid"/>
-                      <a:round/>
-                      <a:headEnd type="none" w="med" len="med"/>
-                      <a:tailEnd type="none" w="med" len="med"/>
-                    </a:lnT>
-                    <a:lnB w="12700" cap="flat" cmpd="sng" algn="ctr">
-                      <a:solidFill>
-                        <a:srgbClr val="D0E1EA"/>
-                      </a:solidFill>
-                      <a:prstDash val="solid"/>
-                      <a:round/>
-                      <a:headEnd type="none" w="med" len="med"/>
-                      <a:tailEnd type="none" w="med" len="med"/>
-                    </a:lnB>
-                    <a:solidFill>
-                      <a:srgbClr val="F0F7FA"/>
-                    </a:solidFill>
-                  </a:tcPr>
-                </a:tc>
-                <a:extLst>
-                  <a:ext uri="{0D108BD9-81ED-4DB2-BD59-A6C34878D82A}">
-                    <a16:rowId xmlns:a16="http://schemas.microsoft.com/office/drawing/2014/main" val="10004"/>
-                  </a:ext>
-                </a:extLst>
-              </a:tr>
-            </a:tbl>
-          </a:graphicData>
-        </a:graphic>
-      </p:graphicFrame>
-      <p:sp>
-        <p:nvSpPr>
-          <p:cNvPr id="6" name="Shape 3"/>
-          <p:cNvSpPr/>
-          <p:nvPr/>
-        </p:nvSpPr>
-        <p:spPr>
-          <a:xfrm>
-            <a:off x="457200" y="3529584"/>
-            <a:ext cx="8229600" cy="914400"/>
-          </a:xfrm>
-          <a:prstGeom prst="rect">
-            <a:avLst/>
-          </a:prstGeom>
-          <a:solidFill>
-            <a:srgbClr val="FFFFFF"/>
-          </a:solidFill>
-          <a:ln w="12700">
-            <a:solidFill>
-              <a:srgbClr val="D0E1EA"/>
-            </a:solidFill>
-            <a:prstDash val="solid"/>
-          </a:ln>
-        </p:spPr>
-        <p:txBody>
-          <a:bodyPr/>
-          <a:lstStyle/>
-          <a:p>
-            <a:endParaRPr lang="pt-BR"/>
-          </a:p>
-        </p:txBody>
-      </p:sp>
-      <p:sp>
-        <p:nvSpPr>
-          <p:cNvPr id="7" name="Shape 4"/>
-          <p:cNvSpPr/>
-          <p:nvPr/>
-        </p:nvSpPr>
-        <p:spPr>
-          <a:xfrm>
-            <a:off x="457200" y="3529584"/>
-            <a:ext cx="45720" cy="914400"/>
-          </a:xfrm>
-          <a:prstGeom prst="rect">
-            <a:avLst/>
-          </a:prstGeom>
-          <a:solidFill>
-            <a:srgbClr val="E63946"/>
-          </a:solidFill>
-          <a:ln w="12700">
-            <a:solidFill>
-              <a:srgbClr val="333333"/>
-            </a:solidFill>
-            <a:prstDash val="solid"/>
-          </a:ln>
-        </p:spPr>
-        <p:txBody>
-          <a:bodyPr/>
-          <a:lstStyle/>
-          <a:p>
-            <a:endParaRPr lang="pt-BR"/>
-          </a:p>
-        </p:txBody>
-      </p:sp>
-      <p:sp>
-        <p:nvSpPr>
-          <p:cNvPr id="8" name="Text 5"/>
-          <p:cNvSpPr/>
-          <p:nvPr/>
-        </p:nvSpPr>
-        <p:spPr>
-          <a:xfrm>
-            <a:off x="621792" y="3621024"/>
-            <a:ext cx="7900416" cy="256032"/>
-          </a:xfrm>
-          <a:prstGeom prst="rect">
-            <a:avLst/>
-          </a:prstGeom>
-          <a:noFill/>
-          <a:ln/>
-        </p:spPr>
-        <p:txBody>
-          <a:bodyPr wrap="square" lIns="0" tIns="0" rIns="0" bIns="0" rtlCol="0" anchor="t"/>
-          <a:lstStyle/>
-          <a:p>
-            <a:pPr marL="0" indent="0">
-              <a:buNone/>
-            </a:pPr>
-            <a:r>
-              <a:rPr lang="en-US" sz="1400" b="1" dirty="0">
-                <a:solidFill>
-                  <a:srgbClr val="E63946"/>
-                </a:solidFill>
-                <a:latin typeface="Calibri" pitchFamily="34" charset="0"/>
-                <a:ea typeface="Calibri" pitchFamily="34" charset="-122"/>
-                <a:cs typeface="Calibri" pitchFamily="34" charset="-120"/>
-              </a:rPr>
-              <a:t>O que zera o critério correspondente</a:t>
-            </a:r>
-            <a:endParaRPr lang="en-US" sz="1400" dirty="0"/>
-          </a:p>
-        </p:txBody>
-      </p:sp>
-      <p:sp>
-        <p:nvSpPr>
-          <p:cNvPr id="9" name="Text 6"/>
-          <p:cNvSpPr/>
-          <p:nvPr/>
-        </p:nvSpPr>
-        <p:spPr>
-          <a:xfrm>
-            <a:off x="621792" y="3913632"/>
-            <a:ext cx="7900416" cy="420624"/>
-          </a:xfrm>
-          <a:prstGeom prst="rect">
-            <a:avLst/>
-          </a:prstGeom>
-          <a:noFill/>
-          <a:ln/>
-        </p:spPr>
-        <p:txBody>
-          <a:bodyPr wrap="square" lIns="0" tIns="0" rIns="0" bIns="0" rtlCol="0" anchor="t"/>
-          <a:lstStyle/>
-          <a:p>
-            <a:pPr marL="342900" indent="-342900">
-              <a:spcAft>
-                <a:spcPts val="500"/>
-              </a:spcAft>
-              <a:buSzPct val="100000"/>
-              <a:buChar char="▪"/>
-            </a:pPr>
-            <a:r>
-              <a:rPr lang="en-US" sz="1100" dirty="0">
-                <a:solidFill>
-                  <a:srgbClr val="334155"/>
-                </a:solidFill>
-                <a:latin typeface="Calibri" pitchFamily="34" charset="0"/>
-                <a:ea typeface="Calibri" pitchFamily="34" charset="-122"/>
-                <a:cs typeface="Calibri" pitchFamily="34" charset="-120"/>
-              </a:rPr>
-              <a:t>História sem critério de aceite preenchido não é contabilizada, conforme a proposta do projeto</a:t>
-            </a:r>
-            <a:endParaRPr lang="en-US" sz="1100" dirty="0"/>
-          </a:p>
-          <a:p>
-            <a:pPr marL="342900" indent="-342900">
-              <a:spcAft>
-                <a:spcPts val="500"/>
-              </a:spcAft>
-              <a:buSzPct val="100000"/>
-              <a:buChar char="▪"/>
-            </a:pPr>
-            <a:r>
-              <a:rPr lang="pt-BR" sz="1100">
-                <a:solidFill>
-                  <a:srgbClr val="334155"/>
-                </a:solidFill>
-                <a:latin typeface="Calibri" pitchFamily="34" charset="0"/>
-                <a:ea typeface="Calibri" pitchFamily="34" charset="-122"/>
-                <a:cs typeface="Calibri" pitchFamily="34" charset="-120"/>
-              </a:rPr>
-              <a:t>Backlog sem ordenação ou história sem estimativa invalidam o critério a que se referem</a:t>
-            </a:r>
-            <a:endParaRPr lang="en-US" sz="1100" dirty="0"/>
-          </a:p>
-        </p:txBody>
-      </p:sp>
-      <p:sp>
-        <p:nvSpPr>
-          <p:cNvPr id="10" name="Shape 7"/>
-          <p:cNvSpPr/>
-          <p:nvPr/>
-        </p:nvSpPr>
-        <p:spPr>
-          <a:xfrm>
-            <a:off x="457200" y="4535424"/>
-            <a:ext cx="8229600" cy="384048"/>
-          </a:xfrm>
-          <a:prstGeom prst="roundRect">
-            <a:avLst>
-              <a:gd name="adj" fmla="val 14286"/>
-            </a:avLst>
-          </a:prstGeom>
-          <a:solidFill>
-            <a:srgbClr val="028090"/>
-          </a:solidFill>
-          <a:ln w="12700">
-            <a:solidFill>
-              <a:srgbClr val="333333"/>
-            </a:solidFill>
-            <a:prstDash val="solid"/>
-          </a:ln>
-        </p:spPr>
-        <p:txBody>
-          <a:bodyPr/>
-          <a:lstStyle/>
-          <a:p>
-            <a:endParaRPr lang="pt-BR"/>
-          </a:p>
-        </p:txBody>
-      </p:sp>
-      <p:sp>
-        <p:nvSpPr>
-          <p:cNvPr id="11" name="Text 8"/>
-          <p:cNvSpPr/>
-          <p:nvPr/>
-        </p:nvSpPr>
-        <p:spPr>
-          <a:xfrm>
-            <a:off x="457200" y="4535424"/>
-            <a:ext cx="8229600" cy="384048"/>
-          </a:xfrm>
-          <a:prstGeom prst="rect">
-            <a:avLst/>
-          </a:prstGeom>
-          <a:noFill/>
-          <a:ln/>
-        </p:spPr>
-        <p:txBody>
-          <a:bodyPr wrap="square" lIns="0" tIns="0" rIns="0" bIns="0" rtlCol="0" anchor="ctr"/>
-          <a:lstStyle/>
-          <a:p>
-            <a:pPr marL="0" indent="0" algn="ctr">
-              <a:buNone/>
-            </a:pPr>
-            <a:r>
-              <a:rPr lang="pt-BR" sz="1150" b="1">
-                <a:solidFill>
-                  <a:srgbClr val="FFFFFF"/>
-                </a:solidFill>
-                <a:latin typeface="Calibri" pitchFamily="34" charset="0"/>
-                <a:ea typeface="Calibri" pitchFamily="34" charset="-122"/>
-                <a:cs typeface="Calibri" pitchFamily="34" charset="-120"/>
-              </a:rPr>
-              <a:t>O roteiro RA-01 em Markdown detalha o que é exigido em cada etapa e os erros mais frequentes</a:t>
-            </a:r>
-            <a:endParaRPr lang="en-US" sz="1150" dirty="0"/>
-          </a:p>
-        </p:txBody>
-      </p:sp>
-    </p:spTree>
-  </p:cSld>
-  <p:clrMapOvr>
-    <a:masterClrMapping/>
-  </p:clrMapOvr>
-</p:sld>
-</file>
-
-<file path=ppt/slides/slide38.xml><?xml version="1.0" encoding="utf-8"?>
-<p:sld xmlns:a="http://schemas.openxmlformats.org/drawingml/2006/main" xmlns:r="http://schemas.openxmlformats.org/officeDocument/2006/relationships" xmlns:p="http://schemas.openxmlformats.org/presentationml/2006/main">
   <p:cSld name="Slide 59">
     <p:bg>
       <p:bgPr>

</xml_diff>

<commit_message>
Reorganiza a Atividade de Requisitos
- Roteiro renomeado para Roteiro_Product_Backlog.md, sem o termo RA-01
- Nomes de equipe e organização definidos pelos alunos; conta institucional (Microsoft Entra ID) obrigatória
- Consulta de Tags compatível com o Azure Boards e registro das decisões nos work items
- Licenças: integrantes Basic e docente Stakeholder
- Remove referências à avaliação do roteiro e das apresentações
- Proposta do projeto: nomes flexíveis e vínculo com o GitHub transferido para a Atividade de Sprint

Co-authored-by: Copilot <223556219+Copilot@users.noreply.github.com>
</commit_message>
<xml_diff>
--- a/Azure_Boards_Product_Backlog.pptx
+++ b/Azure_Boards_Product_Backlog.pptx
@@ -446,7 +446,7 @@
           <a:p>
             <a:r>
               <a:rPr lang="pt-BR"/>
-              <a:t>Apresentação de apoio à primeira atividade do projeto no Azure Boards (RA-01).</a:t>
+              <a:t>Apresentação de apoio à primeira atividade do projeto no Azure Boards (Atividade de Requisitos).</a:t>
             </a:r>
             <a:r>
               <a:rPr lang="en-US"/>
@@ -1072,16 +1072,9 @@
           <a:p>
             <a:r>
               <a:rPr lang="pt-BR"/>
-              <a:t>Esta é a parte central da RA-01: história</a:t>
-            </a:r>
-            <a:r>
-              <a:rPr lang="en-US"/>
-              <a:t> sem critério </a:t>
-            </a:r>
-            <a:r>
-              <a:rPr lang="en-US" dirty="0"/>
-              <a:t>de aceite não é contabilizada.</a:t>
-            </a:r>
+              <a:t>Esta é a parte central da Atividade de Requisitos: história sem critério de aceite não está pronta para entrar em uma sprint.</a:t>
+            </a:r>
+            <a:endParaRPr lang="en-US" dirty="0"/>
           </a:p>
         </p:txBody>
       </p:sp>
@@ -2069,8 +2062,21 @@
           <a:p>
             <a:r>
               <a:rPr lang="en-US" dirty="0"/>
-              <a:t>O apóstrofo em Won't quebra alguns filtros e consultas; padronizar como Wont evita retrabalho na correção automatizada.</a:t>
-            </a:r>
+              <a:t>O apóstrofo em Won't quebra alguns filtros e consultas; padronizar como </a:t>
+            </a:r>
+            <a:r>
+              <a:rPr lang="en-US"/>
+              <a:t>Wont </a:t>
+            </a:r>
+            <a:r>
+              <a:rPr lang="pt-BR"/>
+              <a:t>evita erros nas consultas de verificação</a:t>
+            </a:r>
+            <a:r>
+              <a:rPr lang="en-US"/>
+              <a:t>.</a:t>
+            </a:r>
+            <a:endParaRPr lang="en-US" dirty="0"/>
           </a:p>
         </p:txBody>
       </p:sp>
@@ -2504,8 +2510,17 @@
           <a:p>
             <a:r>
               <a:rPr lang="en-US" dirty="0"/>
-              <a:t>A partir daqui, executar na ferramenta com o projeto aberto. Pressupõe organização e projeto Connexa já criados com o processo Agile.</a:t>
-            </a:r>
+              <a:t>A partir daqui, executar na ferramenta com o projeto aberto</a:t>
+            </a:r>
+            <a:r>
+              <a:rPr lang="en-US"/>
+              <a:t>. </a:t>
+            </a:r>
+            <a:r>
+              <a:rPr lang="pt-BR"/>
+              <a:t>Pressupõe organização criada com a conta institucional e projeto Connexa com o processo Agile.</a:t>
+            </a:r>
+            <a:endParaRPr lang="en-US" dirty="0"/>
           </a:p>
         </p:txBody>
       </p:sp>
@@ -2938,9 +2953,10 @@
           <a:lstStyle/>
           <a:p>
             <a:r>
-              <a:rPr lang="en-US" dirty="0"/>
-              <a:t>Ensinar a consulta de verificação é o que transforma a correção em algo que a própria equipe consegue antecipar.</a:t>
-            </a:r>
+              <a:rPr lang="pt-BR"/>
+              <a:t>Ensinar a consulta de verificação permite que a própria equipe confira a entrega antes de submeter. O Azure Boards não consulta itens sem nenhuma tag; por isso a consulta das Tags procura as que não contêm nenhuma das quatro.</a:t>
+            </a:r>
+            <a:endParaRPr lang="en-US" dirty="0"/>
           </a:p>
         </p:txBody>
       </p:sp>
@@ -3025,8 +3041,16 @@
           <a:lstStyle/>
           <a:p>
             <a:r>
+              <a:rPr lang="pt-BR"/>
+              <a:t>Deixar explícito que o histórico de edição mostra a participação de cada integrante.</a:t>
+            </a:r>
+            <a:r>
+              <a:rPr lang="en-US"/>
+              <a:t> </a:t>
+            </a:r>
+            <a:r>
               <a:rPr lang="en-US" dirty="0"/>
-              <a:t>Deixar explícito que o histórico de edição é consultado. Isso muda o comportamento de equipes em que um integrante faz tudo sozinho na véspera.</a:t>
+              <a:t>Isso muda o comportamento de equipes em que um integrante faz tudo sozinho na véspera.</a:t>
             </a:r>
           </a:p>
         </p:txBody>
@@ -3295,7 +3319,7 @@
             </a:r>
             <a:r>
               <a:rPr lang="pt-BR"/>
-              <a:t>a atividade avaliada agora é o passo 1</a:t>
+              <a:t>a atividade atual cobre o passo 1</a:t>
             </a:r>
             <a:r>
               <a:rPr lang="en-US"/>
@@ -3564,8 +3588,13 @@
           <a:p>
             <a:r>
               <a:rPr lang="en-US" dirty="0"/>
-              <a:t>Ponto sensível: como não há um PO externo, a equipe precisa defender a ordem com argumento tirado do briefing. Isso é avaliado.</a:t>
-            </a:r>
+              <a:t>Ponto sensível: como não há um PO externo, a equipe precisa defender a ordem com argumento tirado do </a:t>
+            </a:r>
+            <a:r>
+              <a:rPr lang="en-US"/>
+              <a:t>briefing.</a:t>
+            </a:r>
+            <a:endParaRPr lang="en-US" dirty="0"/>
           </a:p>
         </p:txBody>
       </p:sp>
@@ -14333,7 +14362,7 @@
                 <a:ea typeface="Calibri" pitchFamily="34" charset="-122"/>
                 <a:cs typeface="Calibri" pitchFamily="34" charset="-120"/>
               </a:rPr>
-              <a:t>RA-01 — Product Backlog</a:t>
+              <a:t>Construção do Product Backlog</a:t>
             </a:r>
             <a:endParaRPr lang="en-US" sz="1400" dirty="0"/>
           </a:p>
@@ -17279,7 +17308,7 @@
               <a:buNone/>
             </a:pPr>
             <a:r>
-              <a:rPr lang="en-US" sz="1300" dirty="0">
+              <a:rPr lang="pt-BR" sz="1300">
                 <a:solidFill>
                   <a:srgbClr val="5A7184"/>
                 </a:solidFill>
@@ -17287,7 +17316,7 @@
                 <a:ea typeface="Calibri" pitchFamily="34" charset="-122"/>
                 <a:cs typeface="Calibri" pitchFamily="34" charset="-120"/>
               </a:rPr>
-              <a:t>Quatro padrões recusados na correção, com a versão corrigida ao lado</a:t>
+              <a:t>Quatro padrões que não servem, com a versão corrigida ao lado</a:t>
             </a:r>
             <a:endParaRPr lang="en-US" sz="1300" dirty="0"/>
           </a:p>
@@ -17302,7 +17331,7 @@
           <p:nvPr>
             <p:extLst>
               <p:ext uri="{D42A27DB-BD31-4B8C-83A1-F6EECF244321}">
-                <p14:modId xmlns:p14="http://schemas.microsoft.com/office/powerpoint/2010/main" val="1579011935"/>
+                <p14:modId xmlns:p14="http://schemas.microsoft.com/office/powerpoint/2010/main" val="775568290"/>
               </p:ext>
             </p:extLst>
           </p:nvPr>
@@ -17348,7 +17377,7 @@
                         <a:buNone/>
                       </a:pPr>
                       <a:r>
-                        <a:rPr lang="en-US" sz="1150" b="1" dirty="0">
+                        <a:rPr lang="en-US" sz="1150" b="1">
                           <a:solidFill>
                             <a:srgbClr val="FFFFFF"/>
                           </a:solidFill>
@@ -17356,7 +17385,7 @@
                           <a:ea typeface="Calibri" pitchFamily="34" charset="-122"/>
                           <a:cs typeface="Calibri" pitchFamily="34" charset="-120"/>
                         </a:rPr>
-                        <a:t>Padrão recusado</a:t>
+                        <a:t>Padrão</a:t>
                       </a:r>
                       <a:endParaRPr lang="en-US" sz="1150" dirty="0">
                         <a:latin typeface="Calibri" charset="0"/>
@@ -25209,7 +25238,7 @@
                 <a:ea typeface="Trebuchet MS" pitchFamily="34" charset="-122"/>
                 <a:cs typeface="Trebuchet MS" pitchFamily="34" charset="-120"/>
               </a:rPr>
-              <a:t>RA-01 — montar</a:t>
+              <a:t>Montar o</a:t>
             </a:r>
             <a:endParaRPr lang="en-US" sz="3400" dirty="0"/>
           </a:p>
@@ -25218,7 +25247,7 @@
               <a:buNone/>
             </a:pPr>
             <a:r>
-              <a:rPr lang="en-US" sz="3400" b="1" dirty="0">
+              <a:rPr lang="en-US" sz="3400" b="1">
                 <a:solidFill>
                   <a:srgbClr val="FFFFFF"/>
                 </a:solidFill>
@@ -25226,7 +25255,7 @@
                 <a:ea typeface="Trebuchet MS" pitchFamily="34" charset="-122"/>
                 <a:cs typeface="Trebuchet MS" pitchFamily="34" charset="-120"/>
               </a:rPr>
-              <a:t>o Product Backlog</a:t>
+              <a:t>Product Backlog</a:t>
             </a:r>
             <a:endParaRPr lang="en-US" sz="3400" dirty="0"/>
           </a:p>
@@ -27412,7 +27441,7 @@
                 <a:ea typeface="Calibri" pitchFamily="34" charset="-122"/>
                 <a:cs typeface="Calibri" pitchFamily="34" charset="-120"/>
               </a:rPr>
-              <a:t>Todos os integrantes com nível Basic e o docente adicionado ao projeto, conforme a proposta do projeto</a:t>
+              <a:t>Integrantes com nível Basic e docente adicionado ao projeto; para o docente, Stakeholder é suficiente</a:t>
             </a:r>
             <a:endParaRPr lang="en-US" sz="1050" dirty="0"/>
           </a:p>
@@ -28952,7 +28981,7 @@
               <a:buNone/>
             </a:pPr>
             <a:r>
-              <a:rPr lang="en-US" sz="1300" dirty="0">
+              <a:rPr lang="pt-BR" sz="1300">
                 <a:solidFill>
                   <a:srgbClr val="5A7184"/>
                 </a:solidFill>
@@ -28960,7 +28989,7 @@
                 <a:ea typeface="Calibri" pitchFamily="34" charset="-122"/>
                 <a:cs typeface="Calibri" pitchFamily="34" charset="-120"/>
               </a:rPr>
-              <a:t>Item incompleto não é contabilizado na correção — a verificação é automatizada</a:t>
+              <a:t>Item sem estes campos deixa o backlog incompleto — as consultas de verificação acusam</a:t>
             </a:r>
             <a:endParaRPr lang="en-US" sz="1300" dirty="0"/>
           </a:p>
@@ -30257,7 +30286,29 @@
                 <a:ea typeface="Calibri" pitchFamily="34" charset="-122"/>
                 <a:cs typeface="Calibri" pitchFamily="34" charset="-120"/>
               </a:rPr>
-              <a:t>A última meia hora da atividade — é onde a maioria dos pontos se ganha ou se perde</a:t>
+              <a:t>A última meia hora da atividade </a:t>
+            </a:r>
+            <a:r>
+              <a:rPr lang="en-US" sz="1300">
+                <a:solidFill>
+                  <a:srgbClr val="5A7184"/>
+                </a:solidFill>
+                <a:latin typeface="Calibri" pitchFamily="34" charset="0"/>
+                <a:ea typeface="Calibri" pitchFamily="34" charset="-122"/>
+                <a:cs typeface="Calibri" pitchFamily="34" charset="-120"/>
+              </a:rPr>
+              <a:t>— </a:t>
+            </a:r>
+            <a:r>
+              <a:rPr lang="pt-BR" sz="1300">
+                <a:solidFill>
+                  <a:srgbClr val="5A7184"/>
+                </a:solidFill>
+                <a:latin typeface="Calibri" pitchFamily="34" charset="0"/>
+                <a:ea typeface="Calibri" pitchFamily="34" charset="-122"/>
+                <a:cs typeface="Calibri" pitchFamily="34" charset="-120"/>
+              </a:rPr>
+              <a:t>é onde a entrega se completa ou fica pela metade</a:t>
             </a:r>
             <a:endParaRPr lang="en-US" sz="1300" dirty="0"/>
           </a:p>
@@ -31096,7 +31147,7 @@
               <a:buNone/>
             </a:pPr>
             <a:r>
-              <a:rPr lang="en-US" sz="1050" dirty="0">
+              <a:rPr lang="pt-BR" sz="1050">
                 <a:solidFill>
                   <a:srgbClr val="334155"/>
                 </a:solidFill>
@@ -31104,7 +31155,7 @@
                 <a:ea typeface="Calibri" pitchFamily="34" charset="-122"/>
                 <a:cs typeface="Calibri" pitchFamily="34" charset="-120"/>
               </a:rPr>
-              <a:t>Repita a mesma consulta trocando o campo: Acceptance Criteria vazio, Description vazio e Tags vazio. Quatro consultas, quatro resultados vazios — a entrega está completa.</a:t>
+              <a:t>Repita com Acceptance Criteria e Description (operador Is Empty) e com Tags que não contêm Must, Should, Could nem Wont. Quatro consultas, quatro resultados vazios.</a:t>
             </a:r>
             <a:endParaRPr lang="en-US" sz="1050" dirty="0"/>
           </a:p>
@@ -31208,7 +31259,7 @@
                 <a:ea typeface="Trebuchet MS" pitchFamily="34" charset="-122"/>
                 <a:cs typeface="Trebuchet MS" pitchFamily="34" charset="-120"/>
               </a:rPr>
-              <a:t>RA-01 — o que entregar</a:t>
+              <a:t>O que entregar</a:t>
             </a:r>
             <a:endParaRPr lang="en-US" sz="2800" dirty="0"/>
           </a:p>
@@ -31239,7 +31290,7 @@
               <a:buNone/>
             </a:pPr>
             <a:r>
-              <a:rPr lang="en-US" sz="1300" dirty="0">
+              <a:rPr lang="pt-BR" sz="1300">
                 <a:solidFill>
                   <a:srgbClr val="5A7184"/>
                 </a:solidFill>
@@ -31247,7 +31298,7 @@
                 <a:ea typeface="Calibri" pitchFamily="34" charset="-122"/>
                 <a:cs typeface="Calibri" pitchFamily="34" charset="-120"/>
               </a:rPr>
-              <a:t>Prazo, escopo mínimo e forma de submissão</a:t>
+              <a:t>Escopo mínimo e forma de submissão</a:t>
             </a:r>
             <a:endParaRPr lang="en-US" sz="1300" dirty="0"/>
           </a:p>
@@ -31690,7 +31741,7 @@
               <a:buNone/>
             </a:pPr>
             <a:r>
-              <a:rPr lang="pt-BR" sz="1050" dirty="0">
+              <a:rPr lang="pt-BR" sz="1050">
                 <a:solidFill>
                   <a:srgbClr val="5A7184"/>
                 </a:solidFill>
@@ -31698,8 +31749,16 @@
                 <a:ea typeface="Calibri" pitchFamily="34" charset="-122"/>
                 <a:cs typeface="Calibri" pitchFamily="34" charset="-120"/>
               </a:rPr>
-              <a:t>Link do projeto no Azure Boards com o docente já adicionado</a:t>
-            </a:r>
+              <a:t>Link do projeto com o docente já adicionado, captura do backlog e nomes da equipe e dos integrantes</a:t>
+            </a:r>
+            <a:endParaRPr lang="pt-BR" sz="1050" dirty="0">
+              <a:solidFill>
+                <a:srgbClr val="5A7184"/>
+              </a:solidFill>
+              <a:latin typeface="Calibri" pitchFamily="34" charset="0"/>
+              <a:ea typeface="Calibri" pitchFamily="34" charset="-122"/>
+              <a:cs typeface="Calibri" pitchFamily="34" charset="-120"/>
+            </a:endParaRPr>
           </a:p>
         </p:txBody>
       </p:sp>
@@ -31881,7 +31940,29 @@
                 <a:ea typeface="Calibri" pitchFamily="34" charset="-122"/>
                 <a:cs typeface="Calibri" pitchFamily="34" charset="-120"/>
               </a:rPr>
-              <a:t>Todos os integrantes precisam ter criado ou editado itens: o histórico do work item é consultado na correção</a:t>
+              <a:t>Todos os integrantes precisam ter criado ou editado itens</a:t>
+            </a:r>
+            <a:r>
+              <a:rPr lang="en-US" sz="1050">
+                <a:solidFill>
+                  <a:srgbClr val="5A7184"/>
+                </a:solidFill>
+                <a:latin typeface="Calibri" pitchFamily="34" charset="0"/>
+                <a:ea typeface="Calibri" pitchFamily="34" charset="-122"/>
+                <a:cs typeface="Calibri" pitchFamily="34" charset="-120"/>
+              </a:rPr>
+              <a:t>: </a:t>
+            </a:r>
+            <a:r>
+              <a:rPr lang="pt-BR" sz="1050">
+                <a:solidFill>
+                  <a:srgbClr val="5A7184"/>
+                </a:solidFill>
+                <a:latin typeface="Calibri" pitchFamily="34" charset="0"/>
+                <a:ea typeface="Calibri" pitchFamily="34" charset="-122"/>
+                <a:cs typeface="Calibri" pitchFamily="34" charset="-120"/>
+              </a:rPr>
+              <a:t>o histórico do work item mostra quem criou e editou cada item</a:t>
             </a:r>
             <a:endParaRPr lang="en-US" sz="1050" dirty="0"/>
           </a:p>
@@ -32126,7 +32207,7 @@
                 <a:ea typeface="Calibri" pitchFamily="34" charset="-122"/>
                 <a:cs typeface="Calibri" pitchFamily="34" charset="-120"/>
               </a:rPr>
-              <a:t>Ler o roteiro RA-01 em Markdown</a:t>
+              <a:t>Ler o roteiro da Atividade de Requisitos</a:t>
             </a:r>
             <a:r>
               <a:rPr lang="en-US" sz="1300">
@@ -32545,7 +32626,7 @@
                 <a:ea typeface="Calibri" pitchFamily="34" charset="-122"/>
                 <a:cs typeface="Calibri" pitchFamily="34" charset="-120"/>
               </a:rPr>
-              <a:t>planejamento e execução da Sprint 1, em roteiro próprio</a:t>
+              <a:t>Atividade de Sprint — Planejamento e Execução da Sprint 1</a:t>
             </a:r>
             <a:endParaRPr lang="en-US" sz="1200" dirty="0"/>
           </a:p>
@@ -33656,7 +33737,7 @@
                 <a:ea typeface="Calibri" pitchFamily="34" charset="-122"/>
                 <a:cs typeface="Calibri" pitchFamily="34" charset="-120"/>
               </a:rPr>
-              <a:t>·  ESTA ATIVIDADE (RA-01)</a:t>
+              <a:t>·  ATIVIDADE DE REQUISITOS</a:t>
             </a:r>
             <a:endParaRPr lang="en-US" sz="1050" dirty="0"/>
           </a:p>
@@ -33853,7 +33934,7 @@
                 <a:ea typeface="Calibri" pitchFamily="34" charset="-122"/>
                 <a:cs typeface="Calibri" pitchFamily="34" charset="-120"/>
               </a:rPr>
-              <a:t>·  ETAPA SEGUINTE</a:t>
+              <a:t>·  ATIVIDADE DE SPRINT</a:t>
             </a:r>
             <a:endParaRPr lang="en-US" sz="1050" dirty="0"/>
           </a:p>

</xml_diff>